<commit_message>
Fix two wording errors in the v0.1 deck
Slide 3 said some testers "hadn't" started their TFG, as if the test
had already run; it has not, so "haven't". Slide 4 said all three
personas rest on "one author's" observation; each comes from a different
author, so "the authors' own observations".

Co-Authored-By: Claude Opus 5 (1M context) <noreply@anthropic.com>
</commit_message>
<xml_diff>
--- a/venture-skeleton-v0.1.pptx
+++ b/venture-skeleton-v0.1.pptx
@@ -4430,7 +4430,7 @@
                 <a:ea typeface="Calibri" pitchFamily="34" charset="-122"/>
                 <a:cs typeface="Calibri" pitchFamily="34" charset="-120"/>
               </a:rPr>
-              <a:t>Evidence strength: MEDIUM – 10 real final-year classmates, one simulated session; some hadn't started their own TFG work yet.</a:t>
+              <a:t>Evidence strength: MEDIUM – 10 real final-year classmates, one simulated session; some haven't started their own TFG work yet.</a:t>
             </a:r>
             <a:endParaRPr lang="en-US" sz="1050" dirty="0"/>
           </a:p>
@@ -5210,7 +5210,7 @@
                 <a:ea typeface="Calibri" pitchFamily="34" charset="-122"/>
                 <a:cs typeface="Calibri" pitchFamily="34" charset="-120"/>
               </a:rPr>
-              <a:t>No persona is validated with real users; all three rest on one author's observation or second-hand reports (personas/selection.md).</a:t>
+              <a:t>No persona is validated with real users; all three rest on the authors' own observations or second-hand reports (personas/selection.md).</a:t>
             </a:r>
             <a:endParaRPr lang="en-US" sz="1200" dirty="0"/>
           </a:p>

</xml_diff>

<commit_message>
Adopt opportunity v02 and update the Venture Skeleton v0.1 deck
- opportunity-v02.md accepted by the team and moved to opportunity.md;
  references in ERRC.md, market-research.md and README updated
- venture-skeleton-v0.1.pptx text brought up to date: TFGPT name,
  deliverable meetings, scoped riskiest assumption, advisor stakeholder
  persona, Wizard-of-Oz result (6/10, CONTINUE) and dates, what changed
  since Session 8, untested falsifiers, next step
- AI usage log rows for the ERRC confirmation and this update

Co-Authored-By: Claude Opus 5.5 <noreply@anthropic.com>
</commit_message>
<xml_diff>
--- a/venture-skeleton-v0.1.pptx
+++ b/venture-skeleton-v0.1.pptx
@@ -1214,7 +1214,7 @@
                 <a:ea typeface="Calibri" pitchFamily="34" charset="-122"/>
                 <a:cs typeface="Calibri" pitchFamily="34" charset="-120"/>
               </a:rPr>
-              <a:t>TFG Copilot · final-year IE students · v0.1 refresh · Session 8</a:t>
+              <a:t>TFGPT · final-year IE students · v0.1, updated 12 Oct 2026 for Group Project I</a:t>
             </a:r>
             <a:endParaRPr lang="en-US" sz="1200" dirty="0"/>
           </a:p>
@@ -1578,7 +1578,7 @@
                           <a:ea typeface="Calibri" pitchFamily="34" charset="-122"/>
                           <a:cs typeface="Calibri" pitchFamily="34" charset="-120"/>
                         </a:rPr>
-                        <a:t>Final-year IE students drift from their TFG's requirements or scope during the ~2-month gaps between deliverable meetings, and find out only at the meeting, after weeks or months of work.</a:t>
+                        <a:t>Final-year IE students drift from their TFG's requirements or scope between deliverable meetings (~2 months in the Computer Science programme we heard about) and find out only at the meeting.</a:t>
                       </a:r>
                       <a:endParaRPr lang="en-US" sz="1050" dirty="0">
                         <a:latin typeface="Calibri" charset="0"/>
@@ -1784,7 +1784,7 @@
                           <a:ea typeface="Calibri" pitchFamily="34" charset="-122"/>
                           <a:cs typeface="Calibri" pitchFamily="34" charset="-120"/>
                         </a:rPr>
-                        <a:t>Enable them to realise when their TFG stops fulfilling its requirements or scope while working between supervisor meetings, so they don't lose weeks or months and deliver on time.</a:t>
+                        <a:t>Enable them to realise when their TFG stops fulfilling its requirements or scope while working between deliverable meetings, so they don't lose weeks or months and deliver on time.</a:t>
                       </a:r>
                       <a:endParaRPr lang="en-US" sz="1050" dirty="0">
                         <a:latin typeface="Calibri" charset="0"/>
@@ -2196,7 +2196,7 @@
                           <a:ea typeface="Calibri" pitchFamily="34" charset="-122"/>
                           <a:cs typeface="Calibri" pitchFamily="34" charset="-120"/>
                         </a:rPr>
-                        <a:t>3 selected: The AI Cross-Checker, The Hopeful AI Improviser, The Accidental Discoverer. Not validated with real users.</a:t>
+                        <a:t>3 student personas: The AI Cross-Checker, The Hopeful AI Improviser, The Accidental Discoverer; 1 stakeholder: The Few-Minutes Advisor. Not validated with real users.</a:t>
                       </a:r>
                       <a:endParaRPr lang="en-US" sz="1050" dirty="0">
                         <a:latin typeface="Calibri" charset="0"/>
@@ -2285,7 +2285,7 @@
                           <a:ea typeface="Courier New" pitchFamily="34" charset="-122"/>
                           <a:cs typeface="Courier New" pitchFamily="34" charset="-120"/>
                         </a:rPr>
-                        <a:t>ai-persona-01..03.md</a:t>
+                        <a:t>ai-persona-01..04.md</a:t>
                       </a:r>
                       <a:endParaRPr lang="en-US" sz="900" dirty="0">
                         <a:latin typeface="Courier New" charset="0"/>
@@ -2423,7 +2423,7 @@
                           <a:ea typeface="Calibri" pitchFamily="34" charset="-122"/>
                           <a:cs typeface="Calibri" pitchFamily="34" charset="-120"/>
                         </a:rPr>
-                        <a:t>Students will use it instead of their AI of choice. IE approval is a gate; adoption is the risk that survives the gate.</a:t>
+                        <a:t>Students will use it instead of their AI of choice for the pre-meeting check, and alongside it for everything else. IE approval is a gate; adoption is the risk that survives the gate.</a:t>
                       </a:r>
                       <a:endParaRPr lang="en-US" sz="1050" dirty="0">
                         <a:latin typeface="Calibri" charset="0"/>
@@ -3041,7 +3041,7 @@
                           <a:ea typeface="Calibri" pitchFamily="34" charset="-122"/>
                           <a:cs typeface="Calibri" pitchFamily="34" charset="-120"/>
                         </a:rPr>
-                        <a:t>Metric: students completing the task without opening their own AI, out of 10. Threshold ≥ 6, committed before the test. Met → CONTINUE, build a working slice. Missed → CHANGE, reframe as a complement and rerun.</a:t>
+                        <a:t>Metric: students completing the task without opening their own AI, out of 10. Threshold ≥ 6, committed before the test. Result: 6 of 10, threshold met → CONTINUE: build a working slice with the IE guidelines loaded.</a:t>
                       </a:r>
                       <a:endParaRPr lang="en-US" sz="1050" dirty="0">
                         <a:latin typeface="Calibri" charset="0"/>
@@ -3198,7 +3198,7 @@
                 <a:ea typeface="Calibri" pitchFamily="34" charset="-122"/>
                 <a:cs typeface="Calibri" pitchFamily="34" charset="-120"/>
               </a:rPr>
-              <a:t>Evidence strength: MEDIUM · Personas: not validated with real users · Recruitment: recruitment.md</a:t>
+              <a:t>Evidence strength: MEDIUM · Personas: not validated with real users · Recruitment: recruitment.md · Strategy: ERRC.md</a:t>
             </a:r>
             <a:endParaRPr lang="en-US" sz="1000" dirty="0"/>
           </a:p>
@@ -3308,7 +3308,7 @@
                 <a:ea typeface="Calibri" pitchFamily="34" charset="-122"/>
                 <a:cs typeface="Calibri" pitchFamily="34" charset="-120"/>
               </a:rPr>
-              <a:t>3 critical personas for the same JTBD · personas/ai-persona-01..03.md, selection.md</a:t>
+              <a:t>3 student personas for the same JTBD, plus the advisor as a stakeholder (ai-persona-04) · selection.md</a:t>
             </a:r>
             <a:endParaRPr lang="en-US" sz="1200" dirty="0"/>
           </a:p>
@@ -4451,7 +4451,7 @@
                 <a:ea typeface="Calibri" pitchFamily="34" charset="-122"/>
                 <a:cs typeface="Calibri" pitchFamily="34" charset="-120"/>
               </a:rPr>
-              <a:t>Met → CONTINUE: build a working slice with the IE guidelines loaded. Missed → CHANGE: reframe as a complement to their own AI and rerun.</a:t>
+              <a:t>Met → CONTINUE, build a working slice; missed → CHANGE, reframe as a complement. Result: 6 of 10, met → CONTINUE.</a:t>
             </a:r>
             <a:endParaRPr lang="en-US" sz="1050" dirty="0"/>
           </a:p>
@@ -4650,7 +4650,7 @@
                 <a:ea typeface="Calibri" pitchFamily="34" charset="-122"/>
                 <a:cs typeface="Calibri" pitchFamily="34" charset="-120"/>
               </a:rPr>
-              <a:t>Sessions: Mon 28 Sep – Fri 2 Oct 2026. Results and decision recorded by Mon 5 Oct 2026.</a:t>
+              <a:t>Sessions held in the last week of September 2026. Results and decision recorded on 11 Oct 2026.</a:t>
             </a:r>
             <a:endParaRPr lang="en-US" sz="1050" dirty="0"/>
           </a:p>
@@ -4693,6 +4693,27 @@
                 <a:cs typeface="Calibri" pitchFamily="34" charset="-120"/>
               </a:rPr>
               <a:t>Reached via the class WhatsApp group and the TFGPT landing page (tfgpt-production.up.railway.app).</a:t>
+            </a:r>
+            <a:endParaRPr lang="en-US" sz="1050" dirty="0"/>
+          </a:p>
+          <a:p>
+            <a:pPr marL="177800" indent="-177800">
+              <a:spcAft>
+                <a:spcPts val="800"/>
+              </a:spcAft>
+              <a:buSzPct val="100000"/>
+              <a:buChar char="•"/>
+            </a:pPr>
+            <a:r>
+              <a:rPr lang="en-US" sz="1050" dirty="0">
+                <a:solidFill>
+                  <a:srgbClr val="1A1A1A"/>
+                </a:solidFill>
+                <a:latin typeface="Calibri" pitchFamily="34" charset="0"/>
+                <a:ea typeface="Calibri" pitchFamily="34" charset="-122"/>
+                <a:cs typeface="Calibri" pitchFamily="34" charset="-120"/>
+              </a:rPr>
+              <a:t>Tested: 5 BCSAI, 2 BBA, 2 BDBA, 1 BAM. 3 of 10 opened their own AI; 4 of 10 checked with Blackboard, a friend, Google or their supervisor.</a:t>
             </a:r>
             <a:endParaRPr lang="en-US" sz="1050" dirty="0"/>
           </a:p>
@@ -4802,7 +4823,7 @@
                 <a:ea typeface="Cambria" pitchFamily="34" charset="-122"/>
                 <a:cs typeface="Cambria" pitchFamily="34" charset="-120"/>
               </a:rPr>
-              <a:t>What Changed Since v0, and What's Still Unknown</a:t>
+              <a:t>What Changed Since Session 8, and What's Unknown</a:t>
             </a:r>
             <a:endParaRPr lang="en-US" sz="2800" dirty="0"/>
           </a:p>
@@ -4841,7 +4862,7 @@
                 <a:ea typeface="Calibri" pitchFamily="34" charset="-122"/>
                 <a:cs typeface="Calibri" pitchFamily="34" charset="-120"/>
               </a:rPr>
-              <a:t>opportunity.md · assumptions.md · interview-evidence.md · personas/selection.md</a:t>
+              <a:t>experiment-card.md · market-research.md · ERRC.md · opportunity.md · personas/selection.md</a:t>
             </a:r>
             <a:endParaRPr lang="en-US" sz="1200" dirty="0"/>
           </a:p>
@@ -4907,7 +4928,7 @@
                 <a:ea typeface="Calibri" pitchFamily="34" charset="-122"/>
                 <a:cs typeface="Calibri" pitchFamily="34" charset="-120"/>
               </a:rPr>
-              <a:t>What changed since v0</a:t>
+              <a:t>What changed since Session 8</a:t>
             </a:r>
             <a:endParaRPr lang="en-US" sz="1300" dirty="0"/>
           </a:p>
@@ -4950,7 +4971,7 @@
                 <a:ea typeface="Calibri" pitchFamily="34" charset="-122"/>
                 <a:cs typeface="Calibri" pitchFamily="34" charset="-120"/>
               </a:rPr>
-              <a:t>The pain point now centres on the ~2-month gap between TFG deliverables, not drift at any stage.</a:t>
+              <a:t>The Wizard-of-Oz test met the bar: 6 of 10 did the tasks without opening their own AI, so the decision is CONTINUE.</a:t>
             </a:r>
             <a:endParaRPr lang="en-US" sz="1200" dirty="0"/>
           </a:p>
@@ -4971,7 +4992,7 @@
                 <a:ea typeface="Calibri" pitchFamily="34" charset="-122"/>
                 <a:cs typeface="Calibri" pitchFamily="34" charset="-120"/>
               </a:rPr>
-              <a:t>The need is reframed as a failsafe: not perfect, but better than anything students have today for knowing they're on track.</a:t>
+              <a:t>Market evidence: the strongest alternative is the student's own ChatGPT or Claude, so TFGPT is used instead of it for the pre-meeting check and alongside it for everything else.</a:t>
             </a:r>
             <a:endParaRPr lang="en-US" sz="1200" dirty="0"/>
           </a:p>
@@ -4992,7 +5013,7 @@
                 <a:ea typeface="Calibri" pitchFamily="34" charset="-122"/>
                 <a:cs typeface="Calibri" pitchFamily="34" charset="-120"/>
               </a:rPr>
-              <a:t>The riskiest assumption is kept (students using it instead of their AI of choice), now with new evidence: one stated, conditional switch tied to keeping context (Participant 02), against a reported worry that university tools run outdated models.</a:t>
+              <a:t>ERRC: no grade or verdict, fixes only for flagged points, guidelines and context preloaded, and a check TFGPT starts itself before each deliverable.</a:t>
             </a:r>
             <a:endParaRPr lang="en-US" sz="1200" dirty="0"/>
           </a:p>
@@ -5058,7 +5079,7 @@
                 <a:ea typeface="Calibri" pitchFamily="34" charset="-122"/>
                 <a:cs typeface="Calibri" pitchFamily="34" charset="-120"/>
               </a:rPr>
-              <a:t>Sprint Goal moved from intention to behaviour</a:t>
+              <a:t>Sprint Goal tested</a:t>
             </a:r>
             <a:endParaRPr lang="en-US" sz="1300" dirty="0"/>
           </a:p>
@@ -5101,7 +5122,7 @@
                 <a:ea typeface="Calibri" pitchFamily="34" charset="-122"/>
                 <a:cs typeface="Calibri" pitchFamily="34" charset="-120"/>
               </a:rPr>
-              <a:t>v0 asked whether students would use a university-proposed tool and engage with it. v0.1 asks whether they actually do their TFG work in it instead of their AI of choice.</a:t>
+              <a:t>v0.1 asked whether students actually do their TFG work in TFGPT instead of their AI of choice. One session says yes for the check (6/10); the next Sprint Goal is the team's decision.</a:t>
             </a:r>
             <a:endParaRPr lang="en-US" sz="1200" dirty="0"/>
           </a:p>
@@ -5210,7 +5231,7 @@
                 <a:ea typeface="Calibri" pitchFamily="34" charset="-122"/>
                 <a:cs typeface="Calibri" pitchFamily="34" charset="-120"/>
               </a:rPr>
-              <a:t>No persona is validated with real users; all three rest on the authors' own observations or second-hand reports (personas/selection.md).</a:t>
+              <a:t>No persona is validated with real users yet (personas/selection.md).</a:t>
             </a:r>
             <a:endParaRPr lang="en-US" sz="1200" dirty="0"/>
           </a:p>
@@ -5231,7 +5252,7 @@
                 <a:ea typeface="Calibri" pitchFamily="34" charset="-122"/>
                 <a:cs typeface="Calibri" pitchFamily="34" charset="-120"/>
               </a:rPr>
-              <a:t>Stated vs. actual switching: Participant 02's switching condition is a stated intention, not observed behaviour (interview-evidence.md, ai-persona-01.md).</a:t>
+              <a:t>Real use: the 6/10 came from one 20-minute session in a simulated chat, not a real deliverable (experiment-card.md).</a:t>
             </a:r>
             <a:endParaRPr lang="en-US" sz="1200" dirty="0"/>
           </a:p>
@@ -5252,7 +5273,7 @@
                 <a:ea typeface="Calibri" pitchFamily="34" charset="-122"/>
                 <a:cs typeface="Calibri" pitchFamily="34" charset="-120"/>
               </a:rPr>
-              <a:t>“Any degree” is still a hypothesis: all evidence so far comes from Computer Science, and AI habits may differ by degree (opportunity.md).</a:t>
+              <a:t>Untested falsifiers: a miss rate above 40% against a supervisor, another LLM giving the same flags for the same effort, and IE's commitment (ERRC.md).</a:t>
             </a:r>
             <a:endParaRPr lang="en-US" sz="1200" dirty="0"/>
           </a:p>
@@ -5400,7 +5421,7 @@
                 <a:ea typeface="Calibri" pitchFamily="34" charset="-122"/>
                 <a:cs typeface="Calibri" pitchFamily="34" charset="-120"/>
               </a:rPr>
-              <a:t>Next: run the test 28 Sep – 2 Oct 2026 and record results by 5 Oct, before the Phase 1 gate (experiment-card.md).</a:t>
+              <a:t>Next: spikes on the blockers (same flags with another LLM, miss rate against a supervisor, access to the guidelines), then a working slice (ERRC.md).</a:t>
             </a:r>
             <a:endParaRPr lang="en-US" sz="1000" dirty="0"/>
           </a:p>

</xml_diff>